<commit_message>
Logitech Q2 FY27: explain the March fiscal year and name quarters by calendar months
Also unescape KPI labels in fill.json so HTML entities do not reach the PowerPoint.

Co-Authored-By: Claude Opus 5.5 <noreply@anthropic.com>
Claude-Session: https://claude.ai/code/session_014JFw9wsnkgedq53FQx57gS
</commit_message>
<xml_diff>
--- a/reports/LOGN_Q2_FY27/Earnings_Update_LOGN_Q2FY27.pptx
+++ b/reports/LOGN_Q2_FY27/Earnings_Update_LOGN_Q2FY27.pptx
@@ -1414,7 +1414,7 @@
         <p:spPr>
           <a:xfrm>
             <a:off x="539496" y="2257933"/>
-            <a:ext cx="6483096" cy="332080"/>
+            <a:ext cx="6483096" cy="488975"/>
           </a:xfrm>
           <a:prstGeom prst="rect">
             <a:avLst/>
@@ -1441,7 +1441,7 @@
                 <a:ea typeface="Nunito" pitchFamily="34" charset="-122"/>
                 <a:cs typeface="Nunito" pitchFamily="34" charset="-120"/>
               </a:rPr>
-              <a:t>Logitech designs mice, keyboards, gaming gear and video-conferencing equipment for consumers and companies, and serves 71% of the Fortune 500. Second-quarter sales were USD 1.22bn. Listed on SIX Swiss Exchange and Nasdaq.</a:t>
+              <a:t>Logitech designs mice, keyboards, gaming gear and video-conferencing equipment for consumers and companies. Its fiscal year ends in March, so fiscal Q2 2027 covers July to September 2026. Quarterly sales: USD 1.22bn. SIX- and Nasdaq-listed.</a:t>
             </a:r>
             <a:endParaRPr lang="en-US" sz="870" dirty="0"/>
           </a:p>
@@ -1455,7 +1455,7 @@
         </p:nvSpPr>
         <p:spPr>
           <a:xfrm>
-            <a:off x="539496" y="2708885"/>
+            <a:off x="539496" y="2865780"/>
             <a:ext cx="6483096" cy="219456"/>
           </a:xfrm>
           <a:prstGeom prst="rect">
@@ -1494,7 +1494,7 @@
         </p:nvSpPr>
         <p:spPr>
           <a:xfrm>
-            <a:off x="539496" y="2969489"/>
+            <a:off x="539496" y="3126384"/>
             <a:ext cx="576072" cy="156896"/>
           </a:xfrm>
           <a:prstGeom prst="rect">
@@ -1533,7 +1533,7 @@
         </p:nvSpPr>
         <p:spPr>
           <a:xfrm>
-            <a:off x="1133856" y="2946629"/>
+            <a:off x="1133856" y="3103524"/>
             <a:ext cx="5888736" cy="156896"/>
           </a:xfrm>
           <a:prstGeom prst="rect">
@@ -1575,7 +1575,7 @@
         </p:nvSpPr>
         <p:spPr>
           <a:xfrm>
-            <a:off x="539496" y="3172104"/>
+            <a:off x="539496" y="3329000"/>
             <a:ext cx="576072" cy="156896"/>
           </a:xfrm>
           <a:prstGeom prst="rect">
@@ -1614,7 +1614,7 @@
         </p:nvSpPr>
         <p:spPr>
           <a:xfrm>
-            <a:off x="1133856" y="3149244"/>
+            <a:off x="1133856" y="3306140"/>
             <a:ext cx="5888736" cy="156896"/>
           </a:xfrm>
           <a:prstGeom prst="rect">
@@ -1656,7 +1656,7 @@
         </p:nvSpPr>
         <p:spPr>
           <a:xfrm>
-            <a:off x="539496" y="3374720"/>
+            <a:off x="539496" y="3531616"/>
             <a:ext cx="576072" cy="156896"/>
           </a:xfrm>
           <a:prstGeom prst="rect">
@@ -1695,7 +1695,7 @@
         </p:nvSpPr>
         <p:spPr>
           <a:xfrm>
-            <a:off x="1133856" y="3351860"/>
+            <a:off x="1133856" y="3508756"/>
             <a:ext cx="5888736" cy="156896"/>
           </a:xfrm>
           <a:prstGeom prst="rect">
@@ -1723,7 +1723,7 @@
                 <a:ea typeface="Nunito" pitchFamily="34" charset="-122"/>
                 <a:cs typeface="Nunito" pitchFamily="34" charset="-120"/>
               </a:rPr>
-              <a:t>Q3 gross margin guided at 41% to 42%, about 200bp lower year on year, on freight and components.</a:t>
+              <a:t>Q3 (October to December) gross margin guided at 41% to 42%, about 200bp lower year on year.</a:t>
             </a:r>
             <a:endParaRPr lang="en-US" sz="870" dirty="0"/>
           </a:p>
@@ -1737,7 +1737,7 @@
         </p:nvSpPr>
         <p:spPr>
           <a:xfrm>
-            <a:off x="539496" y="3577336"/>
+            <a:off x="539496" y="3734232"/>
             <a:ext cx="576072" cy="156896"/>
           </a:xfrm>
           <a:prstGeom prst="rect">
@@ -1776,7 +1776,7 @@
         </p:nvSpPr>
         <p:spPr>
           <a:xfrm>
-            <a:off x="1133856" y="3554476"/>
+            <a:off x="1133856" y="3711372"/>
             <a:ext cx="5888736" cy="156896"/>
           </a:xfrm>
           <a:prstGeom prst="rect">
@@ -1818,7 +1818,7 @@
         </p:nvSpPr>
         <p:spPr>
           <a:xfrm>
-            <a:off x="539496" y="3839388"/>
+            <a:off x="539496" y="3996284"/>
             <a:ext cx="6483096" cy="640080"/>
           </a:xfrm>
           <a:prstGeom prst="rect">
@@ -1843,7 +1843,7 @@
         </p:nvSpPr>
         <p:spPr>
           <a:xfrm>
-            <a:off x="649224" y="3912540"/>
+            <a:off x="649224" y="4069436"/>
             <a:ext cx="1437894" cy="137160"/>
           </a:xfrm>
           <a:prstGeom prst="rect">
@@ -1882,7 +1882,7 @@
         </p:nvSpPr>
         <p:spPr>
           <a:xfrm>
-            <a:off x="649224" y="4049700"/>
+            <a:off x="649224" y="4206596"/>
             <a:ext cx="1437894" cy="201168"/>
           </a:xfrm>
           <a:prstGeom prst="rect">
@@ -1921,7 +1921,7 @@
         </p:nvSpPr>
         <p:spPr>
           <a:xfrm>
-            <a:off x="649224" y="4260012"/>
+            <a:off x="649224" y="4416908"/>
             <a:ext cx="1437894" cy="137160"/>
           </a:xfrm>
           <a:prstGeom prst="rect">
@@ -1960,7 +1960,7 @@
         </p:nvSpPr>
         <p:spPr>
           <a:xfrm>
-            <a:off x="2160270" y="3839388"/>
+            <a:off x="2160270" y="3996284"/>
             <a:ext cx="0" cy="640080"/>
           </a:xfrm>
           <a:prstGeom prst="line">
@@ -1983,7 +1983,7 @@
         </p:nvSpPr>
         <p:spPr>
           <a:xfrm>
-            <a:off x="2269998" y="3912540"/>
+            <a:off x="2269998" y="4069436"/>
             <a:ext cx="1437894" cy="137160"/>
           </a:xfrm>
           <a:prstGeom prst="rect">
@@ -2022,7 +2022,7 @@
         </p:nvSpPr>
         <p:spPr>
           <a:xfrm>
-            <a:off x="2269998" y="4049700"/>
+            <a:off x="2269998" y="4206596"/>
             <a:ext cx="1437894" cy="201168"/>
           </a:xfrm>
           <a:prstGeom prst="rect">
@@ -2061,7 +2061,7 @@
         </p:nvSpPr>
         <p:spPr>
           <a:xfrm>
-            <a:off x="2269998" y="4260012"/>
+            <a:off x="2269998" y="4416908"/>
             <a:ext cx="1437894" cy="137160"/>
           </a:xfrm>
           <a:prstGeom prst="rect">
@@ -2100,7 +2100,7 @@
         </p:nvSpPr>
         <p:spPr>
           <a:xfrm>
-            <a:off x="3781044" y="3839388"/>
+            <a:off x="3781044" y="3996284"/>
             <a:ext cx="0" cy="640080"/>
           </a:xfrm>
           <a:prstGeom prst="line">
@@ -2123,7 +2123,7 @@
         </p:nvSpPr>
         <p:spPr>
           <a:xfrm>
-            <a:off x="3890772" y="3912540"/>
+            <a:off x="3890772" y="4069436"/>
             <a:ext cx="1437894" cy="137160"/>
           </a:xfrm>
           <a:prstGeom prst="rect">
@@ -2162,7 +2162,7 @@
         </p:nvSpPr>
         <p:spPr>
           <a:xfrm>
-            <a:off x="3890772" y="4049700"/>
+            <a:off x="3890772" y="4206596"/>
             <a:ext cx="1437894" cy="201168"/>
           </a:xfrm>
           <a:prstGeom prst="rect">
@@ -2201,7 +2201,7 @@
         </p:nvSpPr>
         <p:spPr>
           <a:xfrm>
-            <a:off x="3890772" y="4260012"/>
+            <a:off x="3890772" y="4416908"/>
             <a:ext cx="1437894" cy="137160"/>
           </a:xfrm>
           <a:prstGeom prst="rect">
@@ -2240,7 +2240,7 @@
         </p:nvSpPr>
         <p:spPr>
           <a:xfrm>
-            <a:off x="5401818" y="3839388"/>
+            <a:off x="5401818" y="3996284"/>
             <a:ext cx="0" cy="640080"/>
           </a:xfrm>
           <a:prstGeom prst="line">
@@ -2263,7 +2263,7 @@
         </p:nvSpPr>
         <p:spPr>
           <a:xfrm>
-            <a:off x="5511546" y="3912540"/>
+            <a:off x="5511546" y="4069436"/>
             <a:ext cx="1437894" cy="137160"/>
           </a:xfrm>
           <a:prstGeom prst="rect">
@@ -2288,7 +2288,7 @@
                 <a:ea typeface="Nunito" pitchFamily="34" charset="-122"/>
                 <a:cs typeface="Nunito" pitchFamily="34" charset="-120"/>
               </a:rPr>
-              <a:t>Q3 gross margin guide</a:t>
+              <a:t>Oct–Dec margin guide</a:t>
             </a:r>
             <a:endParaRPr lang="en-US" sz="700" dirty="0"/>
           </a:p>
@@ -2302,7 +2302,7 @@
         </p:nvSpPr>
         <p:spPr>
           <a:xfrm>
-            <a:off x="5511546" y="4049700"/>
+            <a:off x="5511546" y="4206596"/>
             <a:ext cx="1437894" cy="201168"/>
           </a:xfrm>
           <a:prstGeom prst="rect">
@@ -2341,7 +2341,7 @@
         </p:nvSpPr>
         <p:spPr>
           <a:xfrm>
-            <a:off x="5511546" y="4260012"/>
+            <a:off x="5511546" y="4416908"/>
             <a:ext cx="1437894" cy="137160"/>
           </a:xfrm>
           <a:prstGeom prst="rect">
@@ -2380,7 +2380,7 @@
         </p:nvSpPr>
         <p:spPr>
           <a:xfrm>
-            <a:off x="539496" y="4598340"/>
+            <a:off x="539496" y="4755236"/>
             <a:ext cx="6483096" cy="219456"/>
           </a:xfrm>
           <a:prstGeom prst="rect">
@@ -2419,7 +2419,7 @@
         </p:nvSpPr>
         <p:spPr>
           <a:xfrm>
-            <a:off x="539496" y="4845228"/>
+            <a:off x="539496" y="5002124"/>
             <a:ext cx="6483096" cy="488975"/>
           </a:xfrm>
           <a:prstGeom prst="rect">
@@ -2447,7 +2447,7 @@
                 <a:ea typeface="Nunito" pitchFamily="34" charset="-122"/>
                 <a:cs typeface="Nunito" pitchFamily="34" charset="-120"/>
               </a:rPr>
-              <a:t>Earnings per share beat consensus by 15% and sales by 0.6%, yet the shares fell 10.5% in early trading on 28 October. The guide is the news: third-quarter sales are guided 6% above consensus, but gross margin falls to 41% to 42% from 45.2%, and management expects cost pressure to last through the fourth quarter.</a:t>
+              <a:t>Earnings per share beat consensus by 15% and sales by 0.6%, yet the shares fell 10.5% in early trading on 28 October. The guide is the news: October to December sales are guided 6% above consensus, but gross margin falls to 41% to 42% from 45.2%, and management expects cost pressure to last until March.</a:t>
             </a:r>
             <a:endParaRPr lang="en-US" sz="870" dirty="0"/>
           </a:p>
@@ -2461,7 +2461,7 @@
         </p:nvSpPr>
         <p:spPr>
           <a:xfrm>
-            <a:off x="539496" y="5413756"/>
+            <a:off x="539496" y="5570652"/>
             <a:ext cx="6483096" cy="173736"/>
           </a:xfrm>
           <a:prstGeom prst="rect">
@@ -2514,7 +2514,7 @@
         </p:nvSpPr>
         <p:spPr>
           <a:xfrm>
-            <a:off x="539496" y="5587492"/>
+            <a:off x="539496" y="5744388"/>
             <a:ext cx="6483096" cy="115570"/>
           </a:xfrm>
           <a:prstGeom prst="rect">
@@ -2542,7 +2542,7 @@
                 <a:ea typeface="Nunito" pitchFamily="34" charset="-122"/>
                 <a:cs typeface="Nunito" pitchFamily="34" charset="-120"/>
               </a:rPr>
-              <a:t>Surprise in % · guide = midpoint of the range · Q3 operating income vs. consensus from analyst first takes</a:t>
+              <a:t>Fiscal Q2 = Jul–Sep 2026, Q3 = Oct–Dec 2026 · surprise in % · guide = range midpoint · Q3 operating income consensus from analyst first takes</a:t>
             </a:r>
             <a:endParaRPr lang="en-US" sz="700" dirty="0"/>
           </a:p>
@@ -2564,7 +2564,7 @@
         </p:blipFill>
         <p:spPr>
           <a:xfrm>
-            <a:off x="1641622" y="5748782"/>
+            <a:off x="1641622" y="5905678"/>
             <a:ext cx="4278843" cy="1334999"/>
           </a:xfrm>
           <a:prstGeom prst="rect">
@@ -2580,7 +2580,7 @@
         </p:nvSpPr>
         <p:spPr>
           <a:xfrm>
-            <a:off x="539496" y="7138645"/>
+            <a:off x="539496" y="7295541"/>
             <a:ext cx="6483096" cy="488975"/>
           </a:xfrm>
           <a:prstGeom prst="rect">
@@ -2622,7 +2622,7 @@
         </p:nvSpPr>
         <p:spPr>
           <a:xfrm>
-            <a:off x="539496" y="7743749"/>
+            <a:off x="539496" y="7900645"/>
             <a:ext cx="6483096" cy="219456"/>
           </a:xfrm>
           <a:prstGeom prst="rect">
@@ -2661,7 +2661,7 @@
         </p:nvSpPr>
         <p:spPr>
           <a:xfrm>
-            <a:off x="539496" y="7990637"/>
+            <a:off x="539496" y="8147533"/>
             <a:ext cx="6483096" cy="802767"/>
           </a:xfrm>
           <a:prstGeom prst="rect">
@@ -2689,7 +2689,7 @@
                 <a:ea typeface="Nunito" pitchFamily="34" charset="-122"/>
                 <a:cs typeface="Nunito" pitchFamily="34" charset="-120"/>
               </a:rPr>
-              <a:t>A frustrating quarter: operationally very strong, with share gains and a gross margin well ahead of guidance despite weak PC and European markets, yet overshadowed by an outlook clouded by inflation. We remain constructive, but the fundamental case is exposed to exogenous factors. If freight and component inflation persists into fiscal 2028, it would cap the potential for the Swiss-based company. Conversely, any easing in inflation would benefit Logitech through logistics and component costs. We would wait for that signal before adding; the next test is the January release.</a:t>
+              <a:t>A frustrating quarter: operationally very strong, with share gains and a gross margin well ahead of guidance despite weak PC and European markets, but overshadowed by an inflation-clouded outlook. We remain constructive, but the fundamental case is exposed to exogenous factors. If freight and component inflation persists beyond March 2027, the fiscal year-end, it would cap the potential for the Swiss-based company. Any easing in inflation would benefit Logitech through logistics and component costs. We would wait for that signal before adding; the next test is the January release.</a:t>
             </a:r>
             <a:endParaRPr lang="en-US" sz="870" dirty="0"/>
           </a:p>
@@ -2703,8 +2703,8 @@
         </p:nvSpPr>
         <p:spPr>
           <a:xfrm>
-            <a:off x="3781044" y="8909533"/>
-            <a:ext cx="0" cy="985647"/>
+            <a:off x="3781044" y="9066429"/>
+            <a:ext cx="0" cy="828751"/>
           </a:xfrm>
           <a:prstGeom prst="line">
             <a:avLst/>
@@ -2726,7 +2726,7 @@
         </p:nvSpPr>
         <p:spPr>
           <a:xfrm>
-            <a:off x="539496" y="8909533"/>
+            <a:off x="539496" y="9066429"/>
             <a:ext cx="3058668" cy="155448"/>
           </a:xfrm>
           <a:prstGeom prst="rect">
@@ -2765,8 +2765,8 @@
         </p:nvSpPr>
         <p:spPr>
           <a:xfrm>
-            <a:off x="539496" y="9101557"/>
-            <a:ext cx="3058668" cy="784479"/>
+            <a:off x="539496" y="9258453"/>
+            <a:ext cx="3058668" cy="627583"/>
           </a:xfrm>
           <a:prstGeom prst="rect">
             <a:avLst/>
@@ -2793,7 +2793,7 @@
                 <a:ea typeface="Nunito" pitchFamily="34" charset="-122"/>
                 <a:cs typeface="Nunito" pitchFamily="34" charset="-120"/>
               </a:rPr>
-              <a:t>Fourth-quarter gross margin back above 43% as freight eases; price increases that offset component costs; Video Collaboration growth staying above 10%; Europe returning to sales growth after EMEA fell 6% in the second quarter.</a:t>
+              <a:t>January to March gross margin back above 43% as freight eases; price increases that offset component costs; Video Collaboration growth above 10%; Europe returning to growth after EMEA fell 6% in the second quarter.</a:t>
             </a:r>
             <a:endParaRPr lang="en-US" sz="870" dirty="0"/>
           </a:p>
@@ -2807,7 +2807,7 @@
         </p:nvSpPr>
         <p:spPr>
           <a:xfrm>
-            <a:off x="3963924" y="8909533"/>
+            <a:off x="3963924" y="9066429"/>
             <a:ext cx="3058668" cy="155448"/>
           </a:xfrm>
           <a:prstGeom prst="rect">
@@ -2846,7 +2846,7 @@
         </p:nvSpPr>
         <p:spPr>
           <a:xfrm>
-            <a:off x="3963924" y="9101557"/>
+            <a:off x="3963924" y="9258453"/>
             <a:ext cx="3058668" cy="627583"/>
           </a:xfrm>
           <a:prstGeom prst="rect">
@@ -2874,7 +2874,7 @@
                 <a:ea typeface="Nunito" pitchFamily="34" charset="-122"/>
                 <a:cs typeface="Nunito" pitchFamily="34" charset="-120"/>
               </a:rPr>
-              <a:t>Third-quarter gross margin below 41%, or a further cut for the fourth quarter; a full-year operating margin below 18%; the supplier shortfall running into the fourth quarter; promotions costing more than the 50bp guided.</a:t>
+              <a:t>October to December gross margin below 41%, or a further cut for January to March; a full-year operating margin below 18%; the supplier shortfall running into 2027; promotions costing more than the 50bp guided.</a:t>
             </a:r>
             <a:endParaRPr lang="en-US" sz="870" dirty="0"/>
           </a:p>
@@ -3248,7 +3248,7 @@
         <p:spPr>
           <a:xfrm>
             <a:off x="539496" y="3690899"/>
-            <a:ext cx="6483096" cy="959663"/>
+            <a:ext cx="6483096" cy="802767"/>
           </a:xfrm>
           <a:prstGeom prst="rect">
             <a:avLst/>
@@ -3275,7 +3275,7 @@
                 <a:ea typeface="Nunito" pitchFamily="34" charset="-122"/>
                 <a:cs typeface="Nunito" pitchFamily="34" charset="-120"/>
               </a:rPr>
-              <a:t>Third-quarter sales are guided at USD 1,360m to 1,430m, down 5% to flat in constant currency. Management puts about 5 points of drag on the supplier incident, now USD 70m to 80m after up to USD 200m in July, and about 1 point on the Middle East, so underlying demand runs near +4%. Operating income is guided at USD 220m to 255m. The supplier impact should be largely resolved in the fourth quarter, but freight and component inflation is expected to persist through year-end. The full-year non-GAAP operating margin is still guided to the high end of 15% to 18%, now even excluding the USD 61m of tariff refunds.</a:t>
+              <a:t>For October to December, sales are guided at USD 1,360m to 1,430m, down 5% to flat in constant currency. Management puts about 5 points of drag on the supplier incident, now USD 70m to 80m, and about 1 point on the Middle East, so underlying demand runs near +4%. Operating income is guided at USD 220m to 255m. The supplier impact should be largely resolved in the fourth quarter, but freight and component inflation is expected to persist through year-end. The full-year non-GAAP operating margin is still guided to the high end of 15% to 18%, even excluding the USD 61m of tariff refunds.</a:t>
             </a:r>
             <a:endParaRPr lang="en-US" sz="870" dirty="0"/>
           </a:p>
@@ -3289,7 +3289,7 @@
         </p:nvSpPr>
         <p:spPr>
           <a:xfrm>
-            <a:off x="539496" y="4766691"/>
+            <a:off x="539496" y="4609795"/>
             <a:ext cx="6483096" cy="219456"/>
           </a:xfrm>
           <a:prstGeom prst="rect">
@@ -3328,7 +3328,7 @@
         </p:nvSpPr>
         <p:spPr>
           <a:xfrm>
-            <a:off x="539496" y="5013579"/>
+            <a:off x="539496" y="4856683"/>
             <a:ext cx="6483096" cy="173736"/>
           </a:xfrm>
           <a:prstGeom prst="rect">
@@ -3381,7 +3381,7 @@
         </p:nvSpPr>
         <p:spPr>
           <a:xfrm>
-            <a:off x="539496" y="5187315"/>
+            <a:off x="539496" y="5030419"/>
             <a:ext cx="6483096" cy="115570"/>
           </a:xfrm>
           <a:prstGeom prst="rect">
@@ -3431,7 +3431,7 @@
         </p:blipFill>
         <p:spPr>
           <a:xfrm>
-            <a:off x="928482" y="5348605"/>
+            <a:off x="928482" y="5191709"/>
             <a:ext cx="5705124" cy="3413946"/>
           </a:xfrm>
           <a:prstGeom prst="rect">
@@ -3447,7 +3447,7 @@
         </p:nvSpPr>
         <p:spPr>
           <a:xfrm>
-            <a:off x="539496" y="8817415"/>
+            <a:off x="539496" y="8660520"/>
             <a:ext cx="6483096" cy="802767"/>
           </a:xfrm>
           <a:prstGeom prst="rect">

</xml_diff>